<commit_message>
Added some more useful(mostly free resource links) but need to do some proof reading w.r.t all slides of all trainings since there still seems some typos are there.
</commit_message>
<xml_diff>
--- a/TDD & BDD.pptx
+++ b/TDD & BDD.pptx
@@ -29272,7 +29272,7 @@
           <a:p>
             <a:fld id="{9AE750B3-386C-4233-BFC3-7F4AC971F92C}" type="datetimeFigureOut">
               <a:rPr lang="en-US" smtClean="0"/>
-              <a:t>7/1/2024</a:t>
+              <a:t>8/11/2024</a:t>
             </a:fld>
             <a:endParaRPr lang="en-US" dirty="0"/>
           </a:p>
@@ -29855,7 +29855,7 @@
           <a:p>
             <a:fld id="{1D8BD707-D9CF-40AE-B4C6-C98DA3205C09}" type="datetimeFigureOut">
               <a:rPr lang="en-US"/>
-              <a:t>7/1/2024</a:t>
+              <a:t>8/11/2024</a:t>
             </a:fld>
             <a:endParaRPr lang="en-US" dirty="0"/>
           </a:p>
@@ -30032,7 +30032,7 @@
           <a:p>
             <a:fld id="{1D8BD707-D9CF-40AE-B4C6-C98DA3205C09}" type="datetimeFigureOut">
               <a:rPr lang="en-US"/>
-              <a:t>7/1/2024</a:t>
+              <a:t>8/11/2024</a:t>
             </a:fld>
             <a:endParaRPr lang="en-US" dirty="0"/>
           </a:p>
@@ -30246,7 +30246,7 @@
           <a:p>
             <a:fld id="{1D8BD707-D9CF-40AE-B4C6-C98DA3205C09}" type="datetimeFigureOut">
               <a:rPr lang="en-US"/>
-              <a:t>7/1/2024</a:t>
+              <a:t>8/11/2024</a:t>
             </a:fld>
             <a:endParaRPr lang="en-US" dirty="0"/>
           </a:p>
@@ -30394,7 +30394,7 @@
           <a:p>
             <a:fld id="{1D8BD707-D9CF-40AE-B4C6-C98DA3205C09}" type="datetimeFigureOut">
               <a:rPr lang="en-US"/>
-              <a:t>7/1/2024</a:t>
+              <a:t>8/11/2024</a:t>
             </a:fld>
             <a:endParaRPr lang="en-US" dirty="0"/>
           </a:p>
@@ -30513,7 +30513,7 @@
           <a:p>
             <a:fld id="{1D8BD707-D9CF-40AE-B4C6-C98DA3205C09}" type="datetimeFigureOut">
               <a:rPr lang="en-US"/>
-              <a:t>7/1/2024</a:t>
+              <a:t>8/11/2024</a:t>
             </a:fld>
             <a:endParaRPr lang="en-US" dirty="0"/>
           </a:p>
@@ -30738,7 +30738,7 @@
           <a:p>
             <a:fld id="{1D8BD707-D9CF-40AE-B4C6-C98DA3205C09}" type="datetimeFigureOut">
               <a:rPr lang="en-US"/>
-              <a:t>7/1/2024</a:t>
+              <a:t>8/11/2024</a:t>
             </a:fld>
             <a:endParaRPr lang="en-US" dirty="0"/>
           </a:p>
@@ -31407,6 +31407,94 @@
               <a:t> </a:t>
             </a:r>
             <a:endParaRPr lang="en-US" sz="2400" b="0" kern="0" spc="-80" dirty="0">
+              <a:solidFill>
+                <a:schemeClr val="accent6"/>
+              </a:solidFill>
+            </a:endParaRPr>
+          </a:p>
+        </p:txBody>
+      </p:sp>
+      <p:sp>
+        <p:nvSpPr>
+          <p:cNvPr id="2" name="object 2">
+            <a:extLst>
+              <a:ext uri="{FF2B5EF4-FFF2-40B4-BE49-F238E27FC236}">
+                <a16:creationId xmlns:a16="http://schemas.microsoft.com/office/drawing/2014/main" id="{56B1588E-43A5-7A69-67CC-90FD0CE14336}"/>
+              </a:ext>
+            </a:extLst>
+          </p:cNvPr>
+          <p:cNvSpPr txBox="1">
+            <a:spLocks/>
+          </p:cNvSpPr>
+          <p:nvPr/>
+        </p:nvSpPr>
+        <p:spPr>
+          <a:xfrm>
+            <a:off x="304800" y="4527828"/>
+            <a:ext cx="8610600" cy="1107996"/>
+          </a:xfrm>
+          <a:prstGeom prst="rect">
+            <a:avLst/>
+          </a:prstGeom>
+        </p:spPr>
+        <p:txBody>
+          <a:bodyPr vert="horz" wrap="square" lIns="0" tIns="0" rIns="0" bIns="0" rtlCol="0">
+            <a:spAutoFit/>
+          </a:bodyPr>
+          <a:lstStyle>
+            <a:lvl1pPr>
+              <a:defRPr sz="3200" b="1" i="0">
+                <a:solidFill>
+                  <a:schemeClr val="tx1"/>
+                </a:solidFill>
+                <a:latin typeface="Lucida Sans"/>
+                <a:ea typeface="+mj-ea"/>
+                <a:cs typeface="Lucida Sans"/>
+              </a:defRPr>
+            </a:lvl1pPr>
+          </a:lstStyle>
+          <a:p>
+            <a:pPr marL="12700" marR="5080"/>
+            <a:r>
+              <a:rPr lang="en-US" sz="2400" kern="0" spc="-220" dirty="0">
+                <a:solidFill>
+                  <a:schemeClr val="accent6"/>
+                </a:solidFill>
+              </a:rPr>
+              <a:t>For Further Exploration</a:t>
+            </a:r>
+          </a:p>
+          <a:p>
+            <a:pPr marL="12700" marR="5080"/>
+            <a:r>
+              <a:rPr lang="en-US" sz="2400" b="0" kern="0" spc="-220" dirty="0">
+                <a:solidFill>
+                  <a:schemeClr val="accent6"/>
+                </a:solidFill>
+                <a:hlinkClick r:id="rId8"/>
+              </a:rPr>
+              <a:t>http://xunitpatterns.com/</a:t>
+            </a:r>
+            <a:r>
+              <a:rPr lang="en-US" sz="2400" b="0" kern="0" spc="-220" dirty="0">
+                <a:solidFill>
+                  <a:schemeClr val="accent6"/>
+                </a:solidFill>
+              </a:rPr>
+              <a:t>    </a:t>
+            </a:r>
+          </a:p>
+          <a:p>
+            <a:pPr marL="12700" marR="5080"/>
+            <a:r>
+              <a:rPr lang="en-US" sz="2400" kern="0" spc="-220" dirty="0">
+                <a:solidFill>
+                  <a:schemeClr val="accent6"/>
+                </a:solidFill>
+              </a:rPr>
+              <a:t> </a:t>
+            </a:r>
+            <a:endParaRPr lang="en-US" sz="2400" kern="0" spc="-80" dirty="0">
               <a:solidFill>
                 <a:schemeClr val="accent6"/>
               </a:solidFill>
@@ -35863,6 +35951,21 @@
 </file>
 
 <file path=customXml/item1.xml><?xml version="1.0" encoding="utf-8"?>
+<p:properties xmlns:p="http://schemas.microsoft.com/office/2006/metadata/properties" xmlns:xsi="http://www.w3.org/2001/XMLSchema-instance" xmlns:pc="http://schemas.microsoft.com/office/infopath/2007/PartnerControls">
+  <documentManagement/>
+</p:properties>
+</file>
+
+<file path=customXml/item2.xml><?xml version="1.0" encoding="utf-8"?>
+<?mso-contentType ?>
+<FormTemplates xmlns="http://schemas.microsoft.com/sharepoint/v3/contenttype/forms">
+  <Display>DocumentLibraryForm</Display>
+  <Edit>DocumentLibraryForm</Edit>
+  <New>DocumentLibraryForm</New>
+</FormTemplates>
+</file>
+
+<file path=customXml/item3.xml><?xml version="1.0" encoding="utf-8"?>
 <ct:contentTypeSchema xmlns:ct="http://schemas.microsoft.com/office/2006/metadata/contentType" xmlns:ma="http://schemas.microsoft.com/office/2006/metadata/properties/metaAttributes" ct:_="" ma:_="" ma:contentTypeName="Document" ma:contentTypeID="0x0101008FB92261DF0CF34EB4810633B41F348E" ma:contentTypeVersion="12" ma:contentTypeDescription="Create a new document." ma:contentTypeScope="" ma:versionID="0504b6c5dad5cedb559b2ba5661c1516">
   <xsd:schema xmlns:xsd="http://www.w3.org/2001/XMLSchema" xmlns:xs="http://www.w3.org/2001/XMLSchema" xmlns:p="http://schemas.microsoft.com/office/2006/metadata/properties" xmlns:ns2="73c285a4-81d7-45ed-89e3-084ec343ed0e" xmlns:ns3="9eeb171f-62b6-4207-910a-f222f02eca92" targetNamespace="http://schemas.microsoft.com/office/2006/metadata/properties" ma:root="true" ma:fieldsID="ee446bd52ab24cfc94472a148ee352b7" ns2:_="" ns3:_="">
     <xsd:import namespace="73c285a4-81d7-45ed-89e3-084ec343ed0e"/>
@@ -36079,22 +36182,32 @@
 </ct:contentTypeSchema>
 </file>
 
-<file path=customXml/item2.xml><?xml version="1.0" encoding="utf-8"?>
-<?mso-contentType ?>
-<FormTemplates xmlns="http://schemas.microsoft.com/sharepoint/v3/contenttype/forms">
-  <Display>DocumentLibraryForm</Display>
-  <Edit>DocumentLibraryForm</Edit>
-  <New>DocumentLibraryForm</New>
-</FormTemplates>
+<file path=customXml/itemProps1.xml><?xml version="1.0" encoding="utf-8"?>
+<ds:datastoreItem xmlns:ds="http://schemas.openxmlformats.org/officeDocument/2006/customXml" ds:itemID="{7845EBFA-FEA7-417E-8860-8460D20694CB}">
+  <ds:schemaRefs>
+    <ds:schemaRef ds:uri="http://schemas.openxmlformats.org/package/2006/metadata/core-properties"/>
+    <ds:schemaRef ds:uri="http://www.w3.org/XML/1998/namespace"/>
+    <ds:schemaRef ds:uri="http://schemas.microsoft.com/office/infopath/2007/PartnerControls"/>
+    <ds:schemaRef ds:uri="73c285a4-81d7-45ed-89e3-084ec343ed0e"/>
+    <ds:schemaRef ds:uri="9eeb171f-62b6-4207-910a-f222f02eca92"/>
+    <ds:schemaRef ds:uri="http://schemas.microsoft.com/office/2006/documentManagement/types"/>
+    <ds:schemaRef ds:uri="http://purl.org/dc/elements/1.1/"/>
+    <ds:schemaRef ds:uri="http://schemas.microsoft.com/office/2006/metadata/properties"/>
+    <ds:schemaRef ds:uri="http://purl.org/dc/dcmitype/"/>
+    <ds:schemaRef ds:uri="http://purl.org/dc/terms/"/>
+  </ds:schemaRefs>
+</ds:datastoreItem>
 </file>
 
-<file path=customXml/item3.xml><?xml version="1.0" encoding="utf-8"?>
-<p:properties xmlns:p="http://schemas.microsoft.com/office/2006/metadata/properties" xmlns:xsi="http://www.w3.org/2001/XMLSchema-instance" xmlns:pc="http://schemas.microsoft.com/office/infopath/2007/PartnerControls">
-  <documentManagement/>
-</p:properties>
+<file path=customXml/itemProps2.xml><?xml version="1.0" encoding="utf-8"?>
+<ds:datastoreItem xmlns:ds="http://schemas.openxmlformats.org/officeDocument/2006/customXml" ds:itemID="{E54ED045-44B0-4818-8BF2-60E776B56E88}">
+  <ds:schemaRefs>
+    <ds:schemaRef ds:uri="http://schemas.microsoft.com/sharepoint/v3/contenttype/forms"/>
+  </ds:schemaRefs>
+</ds:datastoreItem>
 </file>
 
-<file path=customXml/itemProps1.xml><?xml version="1.0" encoding="utf-8"?>
+<file path=customXml/itemProps3.xml><?xml version="1.0" encoding="utf-8"?>
 <ds:datastoreItem xmlns:ds="http://schemas.openxmlformats.org/officeDocument/2006/customXml" ds:itemID="{1561FB4F-8CDF-4FC4-86AB-6B9C0823A4A4}">
   <ds:schemaRefs>
     <ds:schemaRef ds:uri="http://schemas.microsoft.com/office/2006/metadata/contentType"/>
@@ -36111,29 +36224,4 @@
     <ds:schemaRef ds:uri="http://schemas.microsoft.com/internal/obd"/>
   </ds:schemaRefs>
 </ds:datastoreItem>
-</file>
-
-<file path=customXml/itemProps2.xml><?xml version="1.0" encoding="utf-8"?>
-<ds:datastoreItem xmlns:ds="http://schemas.openxmlformats.org/officeDocument/2006/customXml" ds:itemID="{E54ED045-44B0-4818-8BF2-60E776B56E88}">
-  <ds:schemaRefs>
-    <ds:schemaRef ds:uri="http://schemas.microsoft.com/sharepoint/v3/contenttype/forms"/>
-  </ds:schemaRefs>
-</ds:datastoreItem>
-</file>
-
-<file path=customXml/itemProps3.xml><?xml version="1.0" encoding="utf-8"?>
-<ds:datastoreItem xmlns:ds="http://schemas.openxmlformats.org/officeDocument/2006/customXml" ds:itemID="{7845EBFA-FEA7-417E-8860-8460D20694CB}">
-  <ds:schemaRefs>
-    <ds:schemaRef ds:uri="http://schemas.openxmlformats.org/package/2006/metadata/core-properties"/>
-    <ds:schemaRef ds:uri="http://www.w3.org/XML/1998/namespace"/>
-    <ds:schemaRef ds:uri="http://schemas.microsoft.com/office/infopath/2007/PartnerControls"/>
-    <ds:schemaRef ds:uri="73c285a4-81d7-45ed-89e3-084ec343ed0e"/>
-    <ds:schemaRef ds:uri="9eeb171f-62b6-4207-910a-f222f02eca92"/>
-    <ds:schemaRef ds:uri="http://schemas.microsoft.com/office/2006/documentManagement/types"/>
-    <ds:schemaRef ds:uri="http://purl.org/dc/elements/1.1/"/>
-    <ds:schemaRef ds:uri="http://schemas.microsoft.com/office/2006/metadata/properties"/>
-    <ds:schemaRef ds:uri="http://purl.org/dc/dcmitype/"/>
-    <ds:schemaRef ds:uri="http://purl.org/dc/terms/"/>
-  </ds:schemaRefs>
-</ds:datastoreItem>
 </file>
</xml_diff>